<commit_message>
Update resume templates from local
</commit_message>
<xml_diff>
--- a/templates/中文履歷_楊上瑋_數據分析師.pptx
+++ b/templates/中文履歷_楊上瑋_數據分析師.pptx
@@ -13646,7 +13646,7 @@
                 <a:cs typeface="Lato"/>
                 <a:sym typeface="Lato"/>
               </a:rPr>
-              <a:t>資料分析與視覺化</a:t>
+              <a:t>資料分析與視覺化: Power BI, Tableau, GA4, Looker Studio, Excel</a:t>
             </a:r>
             <a:r>
               <a:rPr lang="en-US" altLang="zh-TW" sz="1000" dirty="0">
@@ -13658,7 +13658,7 @@
                 <a:cs typeface="Lato"/>
                 <a:sym typeface="Lato"/>
               </a:rPr>
-              <a:t>: Power BI, Tableau, GA4,  Looker Studio, Excel</a:t>
+              <a:t/>
             </a:r>
             <a:endParaRPr lang="en-US" sz="1000" b="0" i="0" u="none" strike="noStrike" cap="none" dirty="0">
               <a:solidFill>
@@ -16877,7 +16877,7 @@
                 <a:latin typeface="微軟正黑體" panose="020B0604030504040204" pitchFamily="34" charset="-120"/>
                 <a:ea typeface="微軟正黑體" panose="020B0604030504040204" pitchFamily="34" charset="-120"/>
               </a:rPr>
-              <a:t>中央研究院人文社會研究中心</a:t>
+              <a:t>中研院人文社會科學研究中心</a:t>
             </a:r>
             <a:endParaRPr dirty="0">
               <a:solidFill>

</xml_diff>